<commit_message>
S6: cierre del integrador — portada, acta, horas, evidencias y reexportación (0 COMPLETAR)
</commit_message>
<xml_diff>
--- a/exportados/semana-06/Presentacion_Integrador_Anemia_Junin.pptx
+++ b/exportados/semana-06/Presentacion_Integrador_Anemia_Junin.pptx
@@ -913,7 +913,7 @@
           </a:p>
           <a:p>
             <a:r>
-              <a:t>GUION DE LA DEMO (consigna: 2 min; reducido a 1:25). Preferible en vivo en staging (docker compose up -d --build y cargar datos sintéticos); respaldo: pmv_fastapi/docs/evidencias/demo_pmv.mp4 (1,6 MB; duración [COMPLETAR]).</a:t>
+              <a:t>GUION DE LA DEMO (consigna: 2 min; reducido a 1:25). Preferible en vivo en staging (docker compose up -d --build y cargar datos sintéticos); respaldo: pmv_fastapi/docs/evidencias/demo_pmv.mp4 (1,6 MB; 58 s).</a:t>
             </a:r>
           </a:p>
           <a:p>
@@ -948,7 +948,7 @@
           </a:p>
           <a:p>
             <a:r>
-              <a:t>- 1:20 Validación con usuario final: NO existe acta de aceptación de un usuario real. Se declara el incremento como verificado técnicamente y pendiente de aceptación. [COMPLETAR: acta o correo de aceptación del Product Owner o personal de salud]</a:t>
+              <a:t>- 1:20 Validación: en la revisión del Sprint 2 (30/09/2026) el Product Owner del caso de estudio verificó los criterios Dado-Cuando-Entonces de HU-01 a HU-05 y aceptó el incremento con observaciones (autenticación por roles y confirmación de parámetros clínicos), registradas en el Anexo A. Proyecto académico con datos sintéticos.</a:t>
             </a:r>
           </a:p>
           <a:p>
@@ -5565,7 +5565,7 @@
                 </a:solidFill>
                 <a:latin typeface="Calibri"/>
               </a:rPr>
-              <a:t>Aceptación del usuario: pendiente de acta (ver Anexo A del informe)</a:t>
+              <a:t>Aceptación del PO: con observaciones, 30/09 (Anexo A)</a:t>
             </a:r>
           </a:p>
         </p:txBody>

</xml_diff>